<commit_message>
Names Added in the Powerpoin
</commit_message>
<xml_diff>
--- a/LabBook_30.pptx
+++ b/LabBook_30.pptx
@@ -2760,18 +2760,11 @@
               </a:spcBef>
             </a:pPr>
             <a:r>
-              <a:rPr lang="es-ES" spc="165" dirty="0" err="1">
-                <a:latin typeface="Arial"/>
-                <a:cs typeface="Arial"/>
-              </a:rPr>
-              <a:t>Student</a:t>
-            </a:r>
-            <a:r>
               <a:rPr lang="es-ES" spc="165" dirty="0">
                 <a:latin typeface="Arial"/>
                 <a:cs typeface="Arial"/>
               </a:rPr>
-              <a:t>: </a:t>
+              <a:t>Student: Candela Molinos Rodriguez-Murcia, Giorgio Andreoli</a:t>
             </a:r>
             <a:endParaRPr sz="1800" dirty="0">
               <a:latin typeface="Arial"/>
@@ -5122,8 +5115,8 @@
           </a:p>
         </p:txBody>
       </p:sp>
-      <mc:AlternateContent xmlns:mc="http://schemas.openxmlformats.org/markup-compatibility/2006">
-        <mc:Choice xmlns:a14="http://schemas.microsoft.com/office/drawing/2010/main" Requires="a14">
+      <mc:AlternateContent xmlns:mc="http://schemas.openxmlformats.org/markup-compatibility/2006" xmlns:a14="http://schemas.microsoft.com/office/drawing/2010/main">
+        <mc:Choice Requires="a14">
           <p:sp>
             <p:nvSpPr>
               <p:cNvPr id="17" name="CasellaDiTesto 16">
@@ -5271,7 +5264,7 @@
             </p:txBody>
           </p:sp>
         </mc:Choice>
-        <mc:Fallback>
+        <mc:Fallback xmlns="">
           <p:sp>
             <p:nvSpPr>
               <p:cNvPr id="17" name="CasellaDiTesto 16">
@@ -5316,8 +5309,8 @@
           </p:sp>
         </mc:Fallback>
       </mc:AlternateContent>
-      <mc:AlternateContent xmlns:mc="http://schemas.openxmlformats.org/markup-compatibility/2006">
-        <mc:Choice xmlns:a14="http://schemas.microsoft.com/office/drawing/2010/main" Requires="a14">
+      <mc:AlternateContent xmlns:mc="http://schemas.openxmlformats.org/markup-compatibility/2006" xmlns:a14="http://schemas.microsoft.com/office/drawing/2010/main">
+        <mc:Choice Requires="a14">
           <p:sp>
             <p:nvSpPr>
               <p:cNvPr id="19" name="CasellaDiTesto 18">
@@ -5431,13 +5424,7 @@
                             <a:rPr lang="en-US" b="0" i="1" smtClean="0">
                               <a:latin typeface="Cambria Math" panose="02040503050406030204" pitchFamily="18" charset="0"/>
                             </a:rPr>
-                            <m:t>2.0∗</m:t>
-                          </m:r>
-                          <m:r>
-                            <a:rPr lang="en-US" b="0" i="1" smtClean="0">
-                              <a:latin typeface="Cambria Math" panose="02040503050406030204" pitchFamily="18" charset="0"/>
-                            </a:rPr>
-                            <m:t>4.2</m:t>
+                            <m:t>2.0∗4.2</m:t>
                           </m:r>
                           <m:r>
                             <a:rPr lang="it-IT" i="1" smtClean="0">
@@ -5480,7 +5467,7 @@
             </p:txBody>
           </p:sp>
         </mc:Choice>
-        <mc:Fallback>
+        <mc:Fallback xmlns="">
           <p:sp>
             <p:nvSpPr>
               <p:cNvPr id="19" name="CasellaDiTesto 18">
@@ -5525,8 +5512,8 @@
           </p:sp>
         </mc:Fallback>
       </mc:AlternateContent>
-      <mc:AlternateContent xmlns:mc="http://schemas.openxmlformats.org/markup-compatibility/2006">
-        <mc:Choice xmlns:a14="http://schemas.microsoft.com/office/drawing/2010/main" Requires="a14">
+      <mc:AlternateContent xmlns:mc="http://schemas.openxmlformats.org/markup-compatibility/2006" xmlns:a14="http://schemas.microsoft.com/office/drawing/2010/main">
+        <mc:Choice Requires="a14">
           <p:sp>
             <p:nvSpPr>
               <p:cNvPr id="21" name="CasellaDiTesto 20">
@@ -5572,13 +5559,7 @@
                         <a:rPr lang="en-US" b="0" i="1" smtClean="0">
                           <a:latin typeface="Cambria Math" panose="02040503050406030204" pitchFamily="18" charset="0"/>
                         </a:rPr>
-                        <m:t>286</m:t>
-                      </m:r>
-                      <m:r>
-                        <a:rPr lang="en-US" b="0" i="1" smtClean="0">
-                          <a:latin typeface="Cambria Math" panose="02040503050406030204" pitchFamily="18" charset="0"/>
-                        </a:rPr>
-                        <m:t>.25 </m:t>
+                        <m:t>286.25 </m:t>
                       </m:r>
                       <m:r>
                         <a:rPr lang="en-US" b="0" i="1" smtClean="0">
@@ -5594,7 +5575,7 @@
             </p:txBody>
           </p:sp>
         </mc:Choice>
-        <mc:Fallback>
+        <mc:Fallback xmlns="">
           <p:sp>
             <p:nvSpPr>
               <p:cNvPr id="21" name="CasellaDiTesto 20">
@@ -6920,8 +6901,8 @@
           </a:p>
         </p:txBody>
       </p:sp>
-      <mc:AlternateContent xmlns:mc="http://schemas.openxmlformats.org/markup-compatibility/2006">
-        <mc:Choice xmlns:a14="http://schemas.microsoft.com/office/drawing/2010/main" Requires="a14">
+      <mc:AlternateContent xmlns:mc="http://schemas.openxmlformats.org/markup-compatibility/2006" xmlns:a14="http://schemas.microsoft.com/office/drawing/2010/main">
+        <mc:Choice Requires="a14">
           <p:sp>
             <p:nvSpPr>
               <p:cNvPr id="9" name="CasellaDiTesto 8">
@@ -7170,13 +7151,7 @@
                           <a:rPr lang="en-US" b="0" i="1" smtClean="0">
                             <a:latin typeface="Cambria Math" panose="02040503050406030204" pitchFamily="18" charset="0"/>
                           </a:rPr>
-                          <m:t> </m:t>
-                        </m:r>
-                        <m:r>
-                          <a:rPr lang="en-US" b="0" i="1" smtClean="0">
-                            <a:latin typeface="Cambria Math" panose="02040503050406030204" pitchFamily="18" charset="0"/>
-                          </a:rPr>
-                          <m:t>2.0</m:t>
+                          <m:t> 2.0</m:t>
                         </m:r>
                         <m:r>
                           <a:rPr lang="en-US" i="1">
@@ -7238,7 +7213,7 @@
             </p:txBody>
           </p:sp>
         </mc:Choice>
-        <mc:Fallback>
+        <mc:Fallback xmlns="">
           <p:sp>
             <p:nvSpPr>
               <p:cNvPr id="9" name="CasellaDiTesto 8">

</xml_diff>